<commit_message>
slides(mmlu): enlarge answers and simplify paper references
</commit_message>
<xml_diff>
--- a/slides/datasets-in-10-minutes-mmlu.pptx
+++ b/slides/datasets-in-10-minutes-mmlu.pptx
@@ -10355,7 +10355,7 @@
                 <a:ea typeface="Noto Sans CJK JP"/>
                 <a:cs typeface="Noto Sans"/>
               </a:rPr>
-              <a:t>論文Table 1の重み付き平均。UnifiedQAは他のQA集合で学習したモデル。</a:t>
+              <a:t>重み付き平均。UnifiedQAは他のQA集合で学習したモデル。</a:t>
             </a:r>
           </a:p>
         </p:txBody>
@@ -13234,8 +13234,8 @@
         </p:nvSpPr>
         <p:spPr>
           <a:xfrm>
-            <a:off x="6583680" y="1271016"/>
-            <a:ext cx="1965960" cy="201168"/>
+            <a:off x="5303520" y="1216152"/>
+            <a:ext cx="3246120" cy="384048"/>
           </a:xfrm>
           <a:prstGeom prst="rect">
             <a:avLst/>
@@ -13243,14 +13243,14 @@
           <a:noFill/>
         </p:spPr>
         <p:txBody>
-          <a:bodyPr wrap="square" lIns="0" rIns="0" tIns="0" bIns="0">
+          <a:bodyPr wrap="none" lIns="0" rIns="0" tIns="0" bIns="0">
             <a:noAutofit/>
           </a:bodyPr>
           <a:lstStyle/>
           <a:p>
-            <a:pPr algn="l">
-              <a:lnSpc>
-                <a:spcPct val="117000"/>
+            <a:pPr algn="r">
+              <a:lnSpc>
+                <a:spcPts val="2640"/>
               </a:lnSpc>
               <a:spcBef>
                 <a:spcPts val="0"/>
@@ -13267,7 +13267,7 @@
               </a:defRPr>
             </a:pPr>
             <a:r>
-              <a:rPr sz="1250" b="1" lang="ja-JP" altLang="en-US">
+              <a:rPr sz="2200" b="1" lang="ja-JP" altLang="en-US">
                 <a:solidFill>
                   <a:srgbClr val="2C9100"/>
                 </a:solidFill>
@@ -14153,8 +14153,8 @@
         </p:nvSpPr>
         <p:spPr>
           <a:xfrm>
-            <a:off x="6583680" y="1271016"/>
-            <a:ext cx="1965960" cy="201168"/>
+            <a:off x="5303520" y="1216152"/>
+            <a:ext cx="3246120" cy="384048"/>
           </a:xfrm>
           <a:prstGeom prst="rect">
             <a:avLst/>
@@ -14162,14 +14162,14 @@
           <a:noFill/>
         </p:spPr>
         <p:txBody>
-          <a:bodyPr wrap="square" lIns="0" rIns="0" tIns="0" bIns="0">
+          <a:bodyPr wrap="none" lIns="0" rIns="0" tIns="0" bIns="0">
             <a:noAutofit/>
           </a:bodyPr>
           <a:lstStyle/>
           <a:p>
-            <a:pPr algn="l">
-              <a:lnSpc>
-                <a:spcPct val="117000"/>
+            <a:pPr algn="r">
+              <a:lnSpc>
+                <a:spcPts val="2640"/>
               </a:lnSpc>
               <a:spcBef>
                 <a:spcPts val="0"/>
@@ -14186,7 +14186,7 @@
               </a:defRPr>
             </a:pPr>
             <a:r>
-              <a:rPr sz="1250" b="1" lang="ja-JP" altLang="en-US">
+              <a:rPr sz="2200" b="1" lang="ja-JP" altLang="en-US">
                 <a:solidFill>
                   <a:srgbClr val="2C9100"/>
                 </a:solidFill>
@@ -15085,8 +15085,8 @@
         </p:nvSpPr>
         <p:spPr>
           <a:xfrm>
-            <a:off x="6583680" y="1271016"/>
-            <a:ext cx="1965960" cy="201168"/>
+            <a:off x="5303520" y="1216152"/>
+            <a:ext cx="3246120" cy="384048"/>
           </a:xfrm>
           <a:prstGeom prst="rect">
             <a:avLst/>
@@ -15094,14 +15094,14 @@
           <a:noFill/>
         </p:spPr>
         <p:txBody>
-          <a:bodyPr wrap="square" lIns="0" rIns="0" tIns="0" bIns="0">
+          <a:bodyPr wrap="none" lIns="0" rIns="0" tIns="0" bIns="0">
             <a:noAutofit/>
           </a:bodyPr>
           <a:lstStyle/>
           <a:p>
-            <a:pPr algn="l">
-              <a:lnSpc>
-                <a:spcPct val="117000"/>
+            <a:pPr algn="r">
+              <a:lnSpc>
+                <a:spcPts val="2640"/>
               </a:lnSpc>
               <a:spcBef>
                 <a:spcPts val="0"/>
@@ -15118,7 +15118,7 @@
               </a:defRPr>
             </a:pPr>
             <a:r>
-              <a:rPr sz="1250" b="1" lang="ja-JP" altLang="en-US">
+              <a:rPr sz="2200" b="1" lang="ja-JP" altLang="en-US">
                 <a:solidFill>
                   <a:srgbClr val="2C9100"/>
                 </a:solidFill>
@@ -15760,8 +15760,8 @@
         </p:nvSpPr>
         <p:spPr>
           <a:xfrm>
-            <a:off x="6583680" y="1271016"/>
-            <a:ext cx="1965960" cy="201168"/>
+            <a:off x="5303520" y="1216152"/>
+            <a:ext cx="3246120" cy="384048"/>
           </a:xfrm>
           <a:prstGeom prst="rect">
             <a:avLst/>
@@ -15769,14 +15769,14 @@
           <a:noFill/>
         </p:spPr>
         <p:txBody>
-          <a:bodyPr wrap="square" lIns="0" rIns="0" tIns="0" bIns="0">
+          <a:bodyPr wrap="none" lIns="0" rIns="0" tIns="0" bIns="0">
             <a:noAutofit/>
           </a:bodyPr>
           <a:lstStyle/>
           <a:p>
-            <a:pPr algn="l">
-              <a:lnSpc>
-                <a:spcPct val="117000"/>
+            <a:pPr algn="r">
+              <a:lnSpc>
+                <a:spcPts val="2640"/>
               </a:lnSpc>
               <a:spcBef>
                 <a:spcPts val="0"/>
@@ -15793,7 +15793,7 @@
               </a:defRPr>
             </a:pPr>
             <a:r>
-              <a:rPr sz="1250" b="1" lang="ja-JP" altLang="en-US">
+              <a:rPr sz="2200" b="1" lang="ja-JP" altLang="en-US">
                 <a:solidFill>
                   <a:srgbClr val="2C9100"/>
                 </a:solidFill>
@@ -16435,8 +16435,8 @@
         </p:nvSpPr>
         <p:spPr>
           <a:xfrm>
-            <a:off x="6583680" y="1271016"/>
-            <a:ext cx="1965960" cy="201168"/>
+            <a:off x="5303520" y="1216152"/>
+            <a:ext cx="3246120" cy="384048"/>
           </a:xfrm>
           <a:prstGeom prst="rect">
             <a:avLst/>
@@ -16444,14 +16444,14 @@
           <a:noFill/>
         </p:spPr>
         <p:txBody>
-          <a:bodyPr wrap="square" lIns="0" rIns="0" tIns="0" bIns="0">
+          <a:bodyPr wrap="none" lIns="0" rIns="0" tIns="0" bIns="0">
             <a:noAutofit/>
           </a:bodyPr>
           <a:lstStyle/>
           <a:p>
-            <a:pPr algn="l">
-              <a:lnSpc>
-                <a:spcPct val="117000"/>
+            <a:pPr algn="r">
+              <a:lnSpc>
+                <a:spcPts val="2640"/>
               </a:lnSpc>
               <a:spcBef>
                 <a:spcPts val="0"/>
@@ -16468,7 +16468,7 @@
               </a:defRPr>
             </a:pPr>
             <a:r>
-              <a:rPr sz="1250" b="1" lang="ja-JP" altLang="en-US">
+              <a:rPr sz="2200" b="1" lang="ja-JP" altLang="en-US">
                 <a:solidFill>
                   <a:srgbClr val="2C9100"/>
                 </a:solidFill>
@@ -17110,8 +17110,8 @@
         </p:nvSpPr>
         <p:spPr>
           <a:xfrm>
-            <a:off x="6583680" y="1271016"/>
-            <a:ext cx="1965960" cy="201168"/>
+            <a:off x="5303520" y="1216152"/>
+            <a:ext cx="3246120" cy="384048"/>
           </a:xfrm>
           <a:prstGeom prst="rect">
             <a:avLst/>
@@ -17119,14 +17119,14 @@
           <a:noFill/>
         </p:spPr>
         <p:txBody>
-          <a:bodyPr wrap="square" lIns="0" rIns="0" tIns="0" bIns="0">
+          <a:bodyPr wrap="none" lIns="0" rIns="0" tIns="0" bIns="0">
             <a:noAutofit/>
           </a:bodyPr>
           <a:lstStyle/>
           <a:p>
-            <a:pPr algn="l">
-              <a:lnSpc>
-                <a:spcPct val="117000"/>
+            <a:pPr algn="r">
+              <a:lnSpc>
+                <a:spcPts val="2640"/>
               </a:lnSpc>
               <a:spcBef>
                 <a:spcPts val="0"/>
@@ -17143,7 +17143,7 @@
               </a:defRPr>
             </a:pPr>
             <a:r>
-              <a:rPr sz="1250" b="1" lang="ja-JP" altLang="en-US">
+              <a:rPr sz="2200" b="1" lang="ja-JP" altLang="en-US">
                 <a:solidFill>
                   <a:srgbClr val="2C9100"/>
                 </a:solidFill>
@@ -17816,8 +17816,8 @@
         </p:nvSpPr>
         <p:spPr>
           <a:xfrm>
-            <a:off x="6583680" y="1271016"/>
-            <a:ext cx="1965960" cy="201168"/>
+            <a:off x="5303520" y="1216152"/>
+            <a:ext cx="3246120" cy="384048"/>
           </a:xfrm>
           <a:prstGeom prst="rect">
             <a:avLst/>
@@ -17825,14 +17825,14 @@
           <a:noFill/>
         </p:spPr>
         <p:txBody>
-          <a:bodyPr wrap="square" lIns="0" rIns="0" tIns="0" bIns="0">
+          <a:bodyPr wrap="none" lIns="0" rIns="0" tIns="0" bIns="0">
             <a:noAutofit/>
           </a:bodyPr>
           <a:lstStyle/>
           <a:p>
-            <a:pPr algn="l">
-              <a:lnSpc>
-                <a:spcPct val="117000"/>
+            <a:pPr algn="r">
+              <a:lnSpc>
+                <a:spcPts val="2640"/>
               </a:lnSpc>
               <a:spcBef>
                 <a:spcPts val="0"/>
@@ -17849,7 +17849,7 @@
               </a:defRPr>
             </a:pPr>
             <a:r>
-              <a:rPr sz="1250" b="1" lang="ja-JP" altLang="en-US">
+              <a:rPr sz="2200" b="1" lang="ja-JP" altLang="en-US">
                 <a:solidFill>
                   <a:srgbClr val="2C9100"/>
                 </a:solidFill>
@@ -18491,8 +18491,8 @@
         </p:nvSpPr>
         <p:spPr>
           <a:xfrm>
-            <a:off x="6583680" y="1271016"/>
-            <a:ext cx="1965960" cy="201168"/>
+            <a:off x="5303520" y="1216152"/>
+            <a:ext cx="3246120" cy="384048"/>
           </a:xfrm>
           <a:prstGeom prst="rect">
             <a:avLst/>
@@ -18500,14 +18500,14 @@
           <a:noFill/>
         </p:spPr>
         <p:txBody>
-          <a:bodyPr wrap="square" lIns="0" rIns="0" tIns="0" bIns="0">
+          <a:bodyPr wrap="none" lIns="0" rIns="0" tIns="0" bIns="0">
             <a:noAutofit/>
           </a:bodyPr>
           <a:lstStyle/>
           <a:p>
-            <a:pPr algn="l">
-              <a:lnSpc>
-                <a:spcPct val="117000"/>
+            <a:pPr algn="r">
+              <a:lnSpc>
+                <a:spcPts val="2640"/>
               </a:lnSpc>
               <a:spcBef>
                 <a:spcPts val="0"/>
@@ -18524,7 +18524,7 @@
               </a:defRPr>
             </a:pPr>
             <a:r>
-              <a:rPr sz="1250" b="1" lang="ja-JP" altLang="en-US">
+              <a:rPr sz="2200" b="1" lang="ja-JP" altLang="en-US">
                 <a:solidFill>
                   <a:srgbClr val="2C9100"/>
                 </a:solidFill>
@@ -19166,8 +19166,8 @@
         </p:nvSpPr>
         <p:spPr>
           <a:xfrm>
-            <a:off x="6583680" y="1271016"/>
-            <a:ext cx="1965960" cy="201168"/>
+            <a:off x="5303520" y="1216152"/>
+            <a:ext cx="3246120" cy="384048"/>
           </a:xfrm>
           <a:prstGeom prst="rect">
             <a:avLst/>
@@ -19175,14 +19175,14 @@
           <a:noFill/>
         </p:spPr>
         <p:txBody>
-          <a:bodyPr wrap="square" lIns="0" rIns="0" tIns="0" bIns="0">
+          <a:bodyPr wrap="none" lIns="0" rIns="0" tIns="0" bIns="0">
             <a:noAutofit/>
           </a:bodyPr>
           <a:lstStyle/>
           <a:p>
-            <a:pPr algn="l">
-              <a:lnSpc>
-                <a:spcPct val="117000"/>
+            <a:pPr algn="r">
+              <a:lnSpc>
+                <a:spcPts val="2640"/>
               </a:lnSpc>
               <a:spcBef>
                 <a:spcPts val="0"/>
@@ -19199,7 +19199,7 @@
               </a:defRPr>
             </a:pPr>
             <a:r>
-              <a:rPr sz="1250" b="1" lang="ja-JP" altLang="en-US">
+              <a:rPr sz="2200" b="1" lang="ja-JP" altLang="en-US">
                 <a:solidFill>
                   <a:srgbClr val="2C9100"/>
                 </a:solidFill>
@@ -19841,8 +19841,8 @@
         </p:nvSpPr>
         <p:spPr>
           <a:xfrm>
-            <a:off x="6583680" y="1271016"/>
-            <a:ext cx="1965960" cy="201168"/>
+            <a:off x="5303520" y="1216152"/>
+            <a:ext cx="3246120" cy="384048"/>
           </a:xfrm>
           <a:prstGeom prst="rect">
             <a:avLst/>
@@ -19850,14 +19850,14 @@
           <a:noFill/>
         </p:spPr>
         <p:txBody>
-          <a:bodyPr wrap="square" lIns="0" rIns="0" tIns="0" bIns="0">
+          <a:bodyPr wrap="none" lIns="0" rIns="0" tIns="0" bIns="0">
             <a:noAutofit/>
           </a:bodyPr>
           <a:lstStyle/>
           <a:p>
-            <a:pPr algn="l">
-              <a:lnSpc>
-                <a:spcPct val="117000"/>
+            <a:pPr algn="r">
+              <a:lnSpc>
+                <a:spcPts val="2640"/>
               </a:lnSpc>
               <a:spcBef>
                 <a:spcPts val="0"/>
@@ -19874,7 +19874,7 @@
               </a:defRPr>
             </a:pPr>
             <a:r>
-              <a:rPr sz="1250" b="1" lang="ja-JP" altLang="en-US">
+              <a:rPr sz="2200" b="1" lang="ja-JP" altLang="en-US">
                 <a:solidFill>
                   <a:srgbClr val="2C9100"/>
                 </a:solidFill>
@@ -32063,8 +32063,8 @@
         </p:nvSpPr>
         <p:spPr>
           <a:xfrm>
-            <a:off x="6583680" y="1271016"/>
-            <a:ext cx="1965960" cy="201168"/>
+            <a:off x="5303520" y="1216152"/>
+            <a:ext cx="3246120" cy="384048"/>
           </a:xfrm>
           <a:prstGeom prst="rect">
             <a:avLst/>
@@ -32072,14 +32072,14 @@
           <a:noFill/>
         </p:spPr>
         <p:txBody>
-          <a:bodyPr wrap="square" lIns="0" rIns="0" tIns="0" bIns="0">
+          <a:bodyPr wrap="none" lIns="0" rIns="0" tIns="0" bIns="0">
             <a:noAutofit/>
           </a:bodyPr>
           <a:lstStyle/>
           <a:p>
-            <a:pPr algn="l">
-              <a:lnSpc>
-                <a:spcPct val="117000"/>
+            <a:pPr algn="r">
+              <a:lnSpc>
+                <a:spcPts val="2640"/>
               </a:lnSpc>
               <a:spcBef>
                 <a:spcPts val="0"/>
@@ -32096,7 +32096,7 @@
               </a:defRPr>
             </a:pPr>
             <a:r>
-              <a:rPr sz="1250" b="1" lang="ja-JP" altLang="en-US">
+              <a:rPr sz="2200" b="1" lang="ja-JP" altLang="en-US">
                 <a:solidFill>
                   <a:srgbClr val="2C9100"/>
                 </a:solidFill>
@@ -32738,8 +32738,8 @@
         </p:nvSpPr>
         <p:spPr>
           <a:xfrm>
-            <a:off x="6583680" y="1271016"/>
-            <a:ext cx="1965960" cy="201168"/>
+            <a:off x="5303520" y="1216152"/>
+            <a:ext cx="3246120" cy="384048"/>
           </a:xfrm>
           <a:prstGeom prst="rect">
             <a:avLst/>
@@ -32747,14 +32747,14 @@
           <a:noFill/>
         </p:spPr>
         <p:txBody>
-          <a:bodyPr wrap="square" lIns="0" rIns="0" tIns="0" bIns="0">
+          <a:bodyPr wrap="none" lIns="0" rIns="0" tIns="0" bIns="0">
             <a:noAutofit/>
           </a:bodyPr>
           <a:lstStyle/>
           <a:p>
-            <a:pPr algn="l">
-              <a:lnSpc>
-                <a:spcPct val="117000"/>
+            <a:pPr algn="r">
+              <a:lnSpc>
+                <a:spcPts val="2640"/>
               </a:lnSpc>
               <a:spcBef>
                 <a:spcPts val="0"/>
@@ -32771,7 +32771,7 @@
               </a:defRPr>
             </a:pPr>
             <a:r>
-              <a:rPr sz="1250" b="1" lang="ja-JP" altLang="en-US">
+              <a:rPr sz="2200" b="1" lang="ja-JP" altLang="en-US">
                 <a:solidFill>
                   <a:srgbClr val="2C9100"/>
                 </a:solidFill>
@@ -33413,8 +33413,8 @@
         </p:nvSpPr>
         <p:spPr>
           <a:xfrm>
-            <a:off x="6583680" y="1271016"/>
-            <a:ext cx="1965960" cy="201168"/>
+            <a:off x="5303520" y="1216152"/>
+            <a:ext cx="3246120" cy="384048"/>
           </a:xfrm>
           <a:prstGeom prst="rect">
             <a:avLst/>
@@ -33422,14 +33422,14 @@
           <a:noFill/>
         </p:spPr>
         <p:txBody>
-          <a:bodyPr wrap="square" lIns="0" rIns="0" tIns="0" bIns="0">
+          <a:bodyPr wrap="none" lIns="0" rIns="0" tIns="0" bIns="0">
             <a:noAutofit/>
           </a:bodyPr>
           <a:lstStyle/>
           <a:p>
-            <a:pPr algn="l">
-              <a:lnSpc>
-                <a:spcPct val="117000"/>
+            <a:pPr algn="r">
+              <a:lnSpc>
+                <a:spcPts val="2640"/>
               </a:lnSpc>
               <a:spcBef>
                 <a:spcPts val="0"/>
@@ -33446,7 +33446,7 @@
               </a:defRPr>
             </a:pPr>
             <a:r>
-              <a:rPr sz="1250" b="1" lang="ja-JP" altLang="en-US">
+              <a:rPr sz="2200" b="1" lang="ja-JP" altLang="en-US">
                 <a:solidFill>
                   <a:srgbClr val="2C9100"/>
                 </a:solidFill>

</xml_diff>

<commit_message>
slides(mmlu): use burgundy theme accent for answers
</commit_message>
<xml_diff>
--- a/slides/datasets-in-10-minutes-mmlu.pptx
+++ b/slides/datasets-in-10-minutes-mmlu.pptx
@@ -13269,7 +13269,7 @@
             <a:r>
               <a:rPr sz="2200" b="1" lang="ja-JP" altLang="en-US">
                 <a:solidFill>
-                  <a:srgbClr val="2C9100"/>
+                  <a:schemeClr val="accent1"/>
                 </a:solidFill>
                 <a:latin typeface="Noto Sans"/>
                 <a:ea typeface="Noto Sans CJK JP"/>
@@ -14188,7 +14188,7 @@
             <a:r>
               <a:rPr sz="2200" b="1" lang="ja-JP" altLang="en-US">
                 <a:solidFill>
-                  <a:srgbClr val="2C9100"/>
+                  <a:schemeClr val="accent1"/>
                 </a:solidFill>
                 <a:latin typeface="Noto Sans"/>
                 <a:ea typeface="Noto Sans CJK JP"/>
@@ -15120,7 +15120,7 @@
             <a:r>
               <a:rPr sz="2200" b="1" lang="ja-JP" altLang="en-US">
                 <a:solidFill>
-                  <a:srgbClr val="2C9100"/>
+                  <a:schemeClr val="accent1"/>
                 </a:solidFill>
                 <a:latin typeface="Noto Sans"/>
                 <a:ea typeface="Noto Sans CJK JP"/>
@@ -15795,7 +15795,7 @@
             <a:r>
               <a:rPr sz="2200" b="1" lang="ja-JP" altLang="en-US">
                 <a:solidFill>
-                  <a:srgbClr val="2C9100"/>
+                  <a:schemeClr val="accent1"/>
                 </a:solidFill>
                 <a:latin typeface="Noto Sans"/>
                 <a:ea typeface="Noto Sans CJK JP"/>
@@ -16470,7 +16470,7 @@
             <a:r>
               <a:rPr sz="2200" b="1" lang="ja-JP" altLang="en-US">
                 <a:solidFill>
-                  <a:srgbClr val="2C9100"/>
+                  <a:schemeClr val="accent1"/>
                 </a:solidFill>
                 <a:latin typeface="Noto Sans"/>
                 <a:ea typeface="Noto Sans CJK JP"/>
@@ -17145,7 +17145,7 @@
             <a:r>
               <a:rPr sz="2200" b="1" lang="ja-JP" altLang="en-US">
                 <a:solidFill>
-                  <a:srgbClr val="2C9100"/>
+                  <a:schemeClr val="accent1"/>
                 </a:solidFill>
                 <a:latin typeface="Noto Sans"/>
                 <a:ea typeface="Noto Sans CJK JP"/>
@@ -17851,7 +17851,7 @@
             <a:r>
               <a:rPr sz="2200" b="1" lang="ja-JP" altLang="en-US">
                 <a:solidFill>
-                  <a:srgbClr val="2C9100"/>
+                  <a:schemeClr val="accent1"/>
                 </a:solidFill>
                 <a:latin typeface="Noto Sans"/>
                 <a:ea typeface="Noto Sans CJK JP"/>
@@ -18526,7 +18526,7 @@
             <a:r>
               <a:rPr sz="2200" b="1" lang="ja-JP" altLang="en-US">
                 <a:solidFill>
-                  <a:srgbClr val="2C9100"/>
+                  <a:schemeClr val="accent1"/>
                 </a:solidFill>
                 <a:latin typeface="Noto Sans"/>
                 <a:ea typeface="Noto Sans CJK JP"/>
@@ -19201,7 +19201,7 @@
             <a:r>
               <a:rPr sz="2200" b="1" lang="ja-JP" altLang="en-US">
                 <a:solidFill>
-                  <a:srgbClr val="2C9100"/>
+                  <a:schemeClr val="accent1"/>
                 </a:solidFill>
                 <a:latin typeface="Noto Sans"/>
                 <a:ea typeface="Noto Sans CJK JP"/>
@@ -19876,7 +19876,7 @@
             <a:r>
               <a:rPr sz="2200" b="1" lang="ja-JP" altLang="en-US">
                 <a:solidFill>
-                  <a:srgbClr val="2C9100"/>
+                  <a:schemeClr val="accent1"/>
                 </a:solidFill>
                 <a:latin typeface="Noto Sans"/>
                 <a:ea typeface="Noto Sans CJK JP"/>
@@ -32098,7 +32098,7 @@
             <a:r>
               <a:rPr sz="2200" b="1" lang="ja-JP" altLang="en-US">
                 <a:solidFill>
-                  <a:srgbClr val="2C9100"/>
+                  <a:schemeClr val="accent1"/>
                 </a:solidFill>
                 <a:latin typeface="Noto Sans"/>
                 <a:ea typeface="Noto Sans CJK JP"/>
@@ -32773,7 +32773,7 @@
             <a:r>
               <a:rPr sz="2200" b="1" lang="ja-JP" altLang="en-US">
                 <a:solidFill>
-                  <a:srgbClr val="2C9100"/>
+                  <a:schemeClr val="accent1"/>
                 </a:solidFill>
                 <a:latin typeface="Noto Sans"/>
                 <a:ea typeface="Noto Sans CJK JP"/>
@@ -33448,7 +33448,7 @@
             <a:r>
               <a:rPr sz="2200" b="1" lang="ja-JP" altLang="en-US">
                 <a:solidFill>
-                  <a:srgbClr val="2C9100"/>
+                  <a:schemeClr val="accent1"/>
                 </a:solidFill>
                 <a:latin typeface="Noto Sans"/>
                 <a:ea typeface="Noto Sans CJK JP"/>

</xml_diff>